<commit_message>
Fixed all views.py bugs
</commit_message>
<xml_diff>
--- a/Final_Curves_and_Surfaces_FullEdition.pptx
+++ b/Final_Curves_and_Surfaces_FullEdition.pptx
@@ -8,21 +8,10 @@
     <p:sldId id="256" r:id="rId2"/>
     <p:sldId id="257" r:id="rId3"/>
     <p:sldId id="258" r:id="rId4"/>
-    <p:sldId id="259" r:id="rId5"/>
-    <p:sldId id="260" r:id="rId6"/>
-    <p:sldId id="261" r:id="rId7"/>
-    <p:sldId id="262" r:id="rId8"/>
-    <p:sldId id="263" r:id="rId9"/>
-    <p:sldId id="264" r:id="rId10"/>
-    <p:sldId id="265" r:id="rId11"/>
-    <p:sldId id="266" r:id="rId12"/>
-    <p:sldId id="267" r:id="rId13"/>
-    <p:sldId id="268" r:id="rId14"/>
-    <p:sldId id="269" r:id="rId15"/>
-    <p:sldId id="270" r:id="rId16"/>
-    <p:sldId id="271" r:id="rId17"/>
-    <p:sldId id="272" r:id="rId18"/>
-    <p:sldId id="273" r:id="rId19"/>
+    <p:sldId id="272" r:id="rId5"/>
+    <p:sldId id="259" r:id="rId6"/>
+    <p:sldId id="260" r:id="rId7"/>
+    <p:sldId id="273" r:id="rId8"/>
   </p:sldIdLst>
   <p:sldSz cx="9144000" cy="6858000" type="screen4x3"/>
   <p:notesSz cx="6858000" cy="9144000"/>
@@ -614,7 +603,7 @@
           <a:p>
             <a:fld id="{5BCAD085-E8A6-8845-BD4E-CB4CCA059FC4}" type="datetimeFigureOut">
               <a:rPr lang="en-US" smtClean="0"/>
-              <a:t>11/30/2025</a:t>
+              <a:t>12/4/2025</a:t>
             </a:fld>
             <a:endParaRPr lang="en-US"/>
           </a:p>
@@ -782,7 +771,7 @@
           <a:p>
             <a:fld id="{5BCAD085-E8A6-8845-BD4E-CB4CCA059FC4}" type="datetimeFigureOut">
               <a:rPr lang="en-US" smtClean="0"/>
-              <a:t>11/30/2025</a:t>
+              <a:t>12/4/2025</a:t>
             </a:fld>
             <a:endParaRPr lang="en-US"/>
           </a:p>
@@ -960,7 +949,7 @@
           <a:p>
             <a:fld id="{5BCAD085-E8A6-8845-BD4E-CB4CCA059FC4}" type="datetimeFigureOut">
               <a:rPr lang="en-US" smtClean="0"/>
-              <a:t>11/30/2025</a:t>
+              <a:t>12/4/2025</a:t>
             </a:fld>
             <a:endParaRPr lang="en-US"/>
           </a:p>
@@ -1128,7 +1117,7 @@
           <a:p>
             <a:fld id="{5BCAD085-E8A6-8845-BD4E-CB4CCA059FC4}" type="datetimeFigureOut">
               <a:rPr lang="en-US" smtClean="0"/>
-              <a:t>11/30/2025</a:t>
+              <a:t>12/4/2025</a:t>
             </a:fld>
             <a:endParaRPr lang="en-US"/>
           </a:p>
@@ -1373,7 +1362,7 @@
           <a:p>
             <a:fld id="{5BCAD085-E8A6-8845-BD4E-CB4CCA059FC4}" type="datetimeFigureOut">
               <a:rPr lang="en-US" smtClean="0"/>
-              <a:t>11/30/2025</a:t>
+              <a:t>12/4/2025</a:t>
             </a:fld>
             <a:endParaRPr lang="en-US"/>
           </a:p>
@@ -1658,7 +1647,7 @@
           <a:p>
             <a:fld id="{5BCAD085-E8A6-8845-BD4E-CB4CCA059FC4}" type="datetimeFigureOut">
               <a:rPr lang="en-US" smtClean="0"/>
-              <a:t>11/30/2025</a:t>
+              <a:t>12/4/2025</a:t>
             </a:fld>
             <a:endParaRPr lang="en-US"/>
           </a:p>
@@ -2077,7 +2066,7 @@
           <a:p>
             <a:fld id="{5BCAD085-E8A6-8845-BD4E-CB4CCA059FC4}" type="datetimeFigureOut">
               <a:rPr lang="en-US" smtClean="0"/>
-              <a:t>11/30/2025</a:t>
+              <a:t>12/4/2025</a:t>
             </a:fld>
             <a:endParaRPr lang="en-US"/>
           </a:p>
@@ -2194,7 +2183,7 @@
           <a:p>
             <a:fld id="{5BCAD085-E8A6-8845-BD4E-CB4CCA059FC4}" type="datetimeFigureOut">
               <a:rPr lang="en-US" smtClean="0"/>
-              <a:t>11/30/2025</a:t>
+              <a:t>12/4/2025</a:t>
             </a:fld>
             <a:endParaRPr lang="en-US"/>
           </a:p>
@@ -2289,7 +2278,7 @@
           <a:p>
             <a:fld id="{5BCAD085-E8A6-8845-BD4E-CB4CCA059FC4}" type="datetimeFigureOut">
               <a:rPr lang="en-US" smtClean="0"/>
-              <a:t>11/30/2025</a:t>
+              <a:t>12/4/2025</a:t>
             </a:fld>
             <a:endParaRPr lang="en-US"/>
           </a:p>
@@ -2564,7 +2553,7 @@
           <a:p>
             <a:fld id="{5BCAD085-E8A6-8845-BD4E-CB4CCA059FC4}" type="datetimeFigureOut">
               <a:rPr lang="en-US" smtClean="0"/>
-              <a:t>11/30/2025</a:t>
+              <a:t>12/4/2025</a:t>
             </a:fld>
             <a:endParaRPr lang="en-US"/>
           </a:p>
@@ -2816,7 +2805,7 @@
           <a:p>
             <a:fld id="{5BCAD085-E8A6-8845-BD4E-CB4CCA059FC4}" type="datetimeFigureOut">
               <a:rPr lang="en-US" smtClean="0"/>
-              <a:t>11/30/2025</a:t>
+              <a:t>12/4/2025</a:t>
             </a:fld>
             <a:endParaRPr lang="en-US"/>
           </a:p>
@@ -3027,7 +3016,7 @@
           <a:p>
             <a:fld id="{5BCAD085-E8A6-8845-BD4E-CB4CCA059FC4}" type="datetimeFigureOut">
               <a:rPr lang="en-US" smtClean="0"/>
-              <a:t>11/30/2025</a:t>
+              <a:t>12/4/2025</a:t>
             </a:fld>
             <a:endParaRPr lang="en-US"/>
           </a:p>
@@ -3447,7 +3436,7 @@
         <p:spPr>
           <a:xfrm>
             <a:off x="914400" y="1828800"/>
-            <a:ext cx="7315200" cy="2743200"/>
+            <a:ext cx="7315200" cy="1815882"/>
           </a:xfrm>
           <a:prstGeom prst="rect">
             <a:avLst/>
@@ -3459,9 +3448,6 @@
             <a:spAutoFit/>
           </a:bodyPr>
           <a:lstStyle/>
-          <a:p>
-            <a:endParaRPr/>
-          </a:p>
           <a:p>
             <a:pPr>
               <a:defRPr sz="2800">
@@ -3471,1424 +3457,58 @@
               </a:defRPr>
             </a:pPr>
             <a:r>
-              <a:t>A complete Python-powered symbolic &amp; numerical geometry platform.</a:t>
-            </a:r>
-            <a:br/>
-            <a:r>
-              <a:t>Includes visuals, step-by-step derivations, code snippets, and styled themes.</a:t>
-            </a:r>
-          </a:p>
-        </p:txBody>
-      </p:sp>
-    </p:spTree>
-  </p:cSld>
-  <p:clrMapOvr>
-    <a:masterClrMapping/>
-  </p:clrMapOvr>
-</p:sld>
-</file>
-
-<file path=ppt/slides/slide10.xml><?xml version="1.0" encoding="utf-8"?>
-<p:sld xmlns:a="http://schemas.openxmlformats.org/drawingml/2006/main" xmlns:r="http://schemas.openxmlformats.org/officeDocument/2006/relationships" xmlns:p="http://schemas.openxmlformats.org/presentationml/2006/main">
-  <p:cSld>
-    <p:bg>
-      <p:bgPr>
-        <a:solidFill>
-          <a:srgbClr val="1E1E2D"/>
-        </a:solidFill>
-        <a:effectLst/>
-      </p:bgPr>
-    </p:bg>
-    <p:spTree>
-      <p:nvGrpSpPr>
-        <p:cNvPr id="1" name=""/>
-        <p:cNvGrpSpPr/>
-        <p:nvPr/>
-      </p:nvGrpSpPr>
-      <p:grpSpPr>
-        <a:xfrm>
-          <a:off x="0" y="0"/>
-          <a:ext cx="0" cy="0"/>
-          <a:chOff x="0" y="0"/>
-          <a:chExt cx="0" cy="0"/>
-        </a:xfrm>
-      </p:grpSpPr>
-      <p:sp>
-        <p:nvSpPr>
-          <p:cNvPr id="2" name="Title 1"/>
-          <p:cNvSpPr>
-            <a:spLocks noGrp="1"/>
-          </p:cNvSpPr>
-          <p:nvPr>
-            <p:ph type="title"/>
-          </p:nvPr>
-        </p:nvSpPr>
-        <p:spPr/>
-        <p:txBody>
-          <a:bodyPr/>
-          <a:lstStyle/>
+              <a:rPr dirty="0"/>
+              <a:t>A complete</a:t>
+            </a:r>
+            <a:r>
+              <a:rPr lang="en-CA" dirty="0"/>
+              <a:t>,</a:t>
+            </a:r>
+            <a:r>
+              <a:rPr dirty="0"/>
+              <a:t> Python-powered </a:t>
+            </a:r>
+            <a:r>
+              <a:rPr lang="en-CA" dirty="0"/>
+              <a:t>differential </a:t>
+            </a:r>
+            <a:r>
+              <a:rPr dirty="0"/>
+              <a:t>geometry </a:t>
+            </a:r>
+            <a:r>
+              <a:rPr lang="en-CA" dirty="0"/>
+              <a:t>calculator</a:t>
+            </a:r>
+          </a:p>
           <a:p>
             <a:pPr>
-              <a:defRPr sz="4400">
+              <a:defRPr sz="2800">
                 <a:solidFill>
                   <a:srgbClr val="FFFFFF"/>
                 </a:solidFill>
               </a:defRPr>
             </a:pPr>
-            <a:r>
-              <a:t>Conclusion</a:t>
-            </a:r>
-          </a:p>
-        </p:txBody>
-      </p:sp>
-      <p:sp>
-        <p:nvSpPr>
-          <p:cNvPr id="4" name="TextBox 3"/>
-          <p:cNvSpPr txBox="1"/>
-          <p:nvPr/>
-        </p:nvSpPr>
-        <p:spPr>
-          <a:xfrm>
-            <a:off x="914400" y="2011680"/>
-            <a:ext cx="7315200" cy="3657600"/>
-          </a:xfrm>
-          <a:prstGeom prst="rect">
-            <a:avLst/>
-          </a:prstGeom>
-          <a:noFill/>
-        </p:spPr>
-        <p:txBody>
-          <a:bodyPr wrap="square">
-            <a:spAutoFit/>
-          </a:bodyPr>
-          <a:lstStyle/>
-          <a:p>
-            <a:endParaRPr/>
-          </a:p>
-          <a:p>
-            <a:pPr>
-              <a:defRPr sz="2400">
-                <a:solidFill>
-                  <a:srgbClr val="FFFFFF"/>
-                </a:solidFill>
-              </a:defRPr>
-            </a:pPr>
-            <a:r>
-              <a:t>Your tool is now a complete mathematical engine:</a:t>
-            </a:r>
-            <a:br/>
-            <a:r>
-              <a:t>- Symbolic &amp; numeric geometry</a:t>
-            </a:r>
-            <a:br/>
-            <a:r>
-              <a:t>- Better than online tools</a:t>
-            </a:r>
-            <a:br/>
-            <a:r>
-              <a:t>- Expandable, customizable, and transparent</a:t>
-            </a:r>
-            <a:br/>
-            <a:r>
-              <a:t>- Suitable for academic presentations &amp; research</a:t>
-            </a:r>
-          </a:p>
-        </p:txBody>
-      </p:sp>
-    </p:spTree>
-  </p:cSld>
-  <p:clrMapOvr>
-    <a:masterClrMapping/>
-  </p:clrMapOvr>
-</p:sld>
-</file>
-
-<file path=ppt/slides/slide11.xml><?xml version="1.0" encoding="utf-8"?>
-<p:sld xmlns:a="http://schemas.openxmlformats.org/drawingml/2006/main" xmlns:r="http://schemas.openxmlformats.org/officeDocument/2006/relationships" xmlns:p="http://schemas.openxmlformats.org/presentationml/2006/main">
-  <p:cSld>
-    <p:bg>
-      <p:bgPr>
-        <a:solidFill>
-          <a:srgbClr val="1E1E2D"/>
-        </a:solidFill>
-        <a:effectLst/>
-      </p:bgPr>
-    </p:bg>
-    <p:spTree>
-      <p:nvGrpSpPr>
-        <p:cNvPr id="1" name=""/>
-        <p:cNvGrpSpPr/>
-        <p:nvPr/>
-      </p:nvGrpSpPr>
-      <p:grpSpPr>
-        <a:xfrm>
-          <a:off x="0" y="0"/>
-          <a:ext cx="0" cy="0"/>
-          <a:chOff x="0" y="0"/>
-          <a:chExt cx="0" cy="0"/>
-        </a:xfrm>
-      </p:grpSpPr>
-      <p:sp>
-        <p:nvSpPr>
-          <p:cNvPr id="2" name="Title 1"/>
-          <p:cNvSpPr>
-            <a:spLocks noGrp="1"/>
-          </p:cNvSpPr>
-          <p:nvPr>
-            <p:ph type="title"/>
-          </p:nvPr>
-        </p:nvSpPr>
-        <p:spPr/>
-        <p:txBody>
-          <a:bodyPr/>
-          <a:lstStyle/>
-          <a:p>
-            <a:pPr>
-              <a:defRPr sz="4000">
-                <a:solidFill>
-                  <a:srgbClr val="FFFFFF"/>
-                </a:solidFill>
-              </a:defRPr>
-            </a:pPr>
-            <a:r>
-              <a:rPr dirty="0"/>
-              <a:t>Comparison vs. Mathematica (Expanded)</a:t>
-            </a:r>
-          </a:p>
-        </p:txBody>
-      </p:sp>
-      <p:sp>
-        <p:nvSpPr>
-          <p:cNvPr id="4" name="TextBox 3"/>
-          <p:cNvSpPr txBox="1"/>
-          <p:nvPr/>
-        </p:nvSpPr>
-        <p:spPr>
-          <a:xfrm>
-            <a:off x="457200" y="1441235"/>
-            <a:ext cx="8229600" cy="3693319"/>
-          </a:xfrm>
-          <a:prstGeom prst="rect">
-            <a:avLst/>
-          </a:prstGeom>
-          <a:noFill/>
-        </p:spPr>
-        <p:txBody>
-          <a:bodyPr wrap="square">
-            <a:spAutoFit/>
-          </a:bodyPr>
-          <a:lstStyle/>
-          <a:p>
+            <a:br>
+              <a:rPr dirty="0"/>
+            </a:br>
+            <a:r>
+              <a:rPr dirty="0"/>
+              <a:t>Includes visuals</a:t>
+            </a:r>
+            <a:r>
+              <a:rPr lang="en-CA" dirty="0"/>
+              <a:t> and</a:t>
+            </a:r>
+            <a:r>
+              <a:rPr dirty="0"/>
+              <a:t> step-by-step </a:t>
+            </a:r>
+            <a:r>
+              <a:rPr lang="en-CA" dirty="0"/>
+              <a:t>computations</a:t>
+            </a:r>
             <a:endParaRPr dirty="0"/>
-          </a:p>
-          <a:p>
-            <a:pPr>
-              <a:defRPr sz="2400">
-                <a:solidFill>
-                  <a:srgbClr val="FFFFFF"/>
-                </a:solidFill>
-              </a:defRPr>
-            </a:pPr>
-            <a:r>
-              <a:rPr dirty="0"/>
-              <a:t>- No licensing cost – Mathematica requires expensive yearly </a:t>
-            </a:r>
-            <a:r>
-              <a:rPr lang="en-US" dirty="0"/>
-              <a:t>							</a:t>
-            </a:r>
-            <a:r>
-              <a:rPr dirty="0"/>
-              <a:t>fees.</a:t>
-            </a:r>
-            <a:br>
-              <a:rPr dirty="0"/>
-            </a:br>
-            <a:r>
-              <a:rPr dirty="0"/>
-              <a:t>- Python ecosystem – integrate NumPy, </a:t>
-            </a:r>
-            <a:r>
-              <a:rPr dirty="0" err="1"/>
-              <a:t>SymPy</a:t>
-            </a:r>
-            <a:r>
-              <a:rPr dirty="0"/>
-              <a:t>, SciPy, </a:t>
-            </a:r>
-            <a:r>
-              <a:rPr lang="en-US" dirty="0"/>
-              <a:t>									</a:t>
-            </a:r>
-            <a:r>
-              <a:rPr dirty="0"/>
-              <a:t>Matplotlib, </a:t>
-            </a:r>
-            <a:r>
-              <a:rPr dirty="0" err="1"/>
-              <a:t>Plotly</a:t>
-            </a:r>
-            <a:r>
-              <a:rPr dirty="0"/>
-              <a:t>.</a:t>
-            </a:r>
-            <a:br>
-              <a:rPr dirty="0"/>
-            </a:br>
-            <a:r>
-              <a:rPr dirty="0"/>
-              <a:t>- Runs inside a browser – no heavy software installation.</a:t>
-            </a:r>
-            <a:br>
-              <a:rPr dirty="0"/>
-            </a:br>
-            <a:r>
-              <a:rPr dirty="0"/>
-              <a:t>- Customizable UI – modify HTML/CSS/JS freely.</a:t>
-            </a:r>
-            <a:br>
-              <a:rPr dirty="0"/>
-            </a:br>
-            <a:r>
-              <a:rPr dirty="0"/>
-              <a:t>- Direct access to symbolic engine – no black-box algebra steps.</a:t>
-            </a:r>
-            <a:br>
-              <a:rPr dirty="0"/>
-            </a:br>
-            <a:r>
-              <a:rPr dirty="0"/>
-              <a:t>- Fully transparent algorithms – user sees exactly how κ, τ, K, H </a:t>
-            </a:r>
-            <a:r>
-              <a:rPr lang="en-US" dirty="0"/>
-              <a:t>									</a:t>
-            </a:r>
-            <a:r>
-              <a:rPr dirty="0"/>
-              <a:t>are computed.</a:t>
-            </a:r>
-          </a:p>
-        </p:txBody>
-      </p:sp>
-    </p:spTree>
-  </p:cSld>
-  <p:clrMapOvr>
-    <a:masterClrMapping/>
-  </p:clrMapOvr>
-</p:sld>
-</file>
-
-<file path=ppt/slides/slide12.xml><?xml version="1.0" encoding="utf-8"?>
-<p:sld xmlns:a="http://schemas.openxmlformats.org/drawingml/2006/main" xmlns:r="http://schemas.openxmlformats.org/officeDocument/2006/relationships" xmlns:p="http://schemas.openxmlformats.org/presentationml/2006/main">
-  <p:cSld>
-    <p:bg>
-      <p:bgPr>
-        <a:solidFill>
-          <a:srgbClr val="1E1E2D"/>
-        </a:solidFill>
-        <a:effectLst/>
-      </p:bgPr>
-    </p:bg>
-    <p:spTree>
-      <p:nvGrpSpPr>
-        <p:cNvPr id="1" name=""/>
-        <p:cNvGrpSpPr/>
-        <p:nvPr/>
-      </p:nvGrpSpPr>
-      <p:grpSpPr>
-        <a:xfrm>
-          <a:off x="0" y="0"/>
-          <a:ext cx="0" cy="0"/>
-          <a:chOff x="0" y="0"/>
-          <a:chExt cx="0" cy="0"/>
-        </a:xfrm>
-      </p:grpSpPr>
-      <p:sp>
-        <p:nvSpPr>
-          <p:cNvPr id="2" name="Title 1"/>
-          <p:cNvSpPr>
-            <a:spLocks noGrp="1"/>
-          </p:cNvSpPr>
-          <p:nvPr>
-            <p:ph type="title"/>
-          </p:nvPr>
-        </p:nvSpPr>
-        <p:spPr/>
-        <p:txBody>
-          <a:bodyPr/>
-          <a:lstStyle/>
-          <a:p>
-            <a:pPr>
-              <a:defRPr sz="4000">
-                <a:solidFill>
-                  <a:srgbClr val="FFFFFF"/>
-                </a:solidFill>
-              </a:defRPr>
-            </a:pPr>
-            <a:r>
-              <a:t>Comparison vs Online Graphing Tools</a:t>
-            </a:r>
-          </a:p>
-        </p:txBody>
-      </p:sp>
-      <p:sp>
-        <p:nvSpPr>
-          <p:cNvPr id="4" name="TextBox 3"/>
-          <p:cNvSpPr txBox="1"/>
-          <p:nvPr/>
-        </p:nvSpPr>
-        <p:spPr>
-          <a:xfrm>
-            <a:off x="585019" y="1645920"/>
-            <a:ext cx="8229600" cy="2954655"/>
-          </a:xfrm>
-          <a:prstGeom prst="rect">
-            <a:avLst/>
-          </a:prstGeom>
-          <a:noFill/>
-        </p:spPr>
-        <p:txBody>
-          <a:bodyPr wrap="square">
-            <a:spAutoFit/>
-          </a:bodyPr>
-          <a:lstStyle/>
-          <a:p>
-            <a:endParaRPr dirty="0"/>
-          </a:p>
-          <a:p>
-            <a:pPr>
-              <a:defRPr sz="2400">
-                <a:solidFill>
-                  <a:srgbClr val="FFFFFF"/>
-                </a:solidFill>
-              </a:defRPr>
-            </a:pPr>
-            <a:r>
-              <a:rPr dirty="0"/>
-              <a:t>- Most online tools only graph – no symbolic differentiation.</a:t>
-            </a:r>
-            <a:br>
-              <a:rPr dirty="0"/>
-            </a:br>
-            <a:r>
-              <a:rPr dirty="0"/>
-              <a:t>- No curvature, torsion, or </a:t>
-            </a:r>
-            <a:r>
-              <a:rPr dirty="0" err="1"/>
-              <a:t>Frenet</a:t>
-            </a:r>
-            <a:r>
-              <a:rPr dirty="0"/>
-              <a:t>–Serret in Desmos, GeoGebra, </a:t>
-            </a:r>
-            <a:r>
-              <a:rPr dirty="0" err="1"/>
-              <a:t>Symbolab</a:t>
-            </a:r>
-            <a:r>
-              <a:rPr dirty="0"/>
-              <a:t>.</a:t>
-            </a:r>
-            <a:br>
-              <a:rPr dirty="0"/>
-            </a:br>
-            <a:r>
-              <a:rPr dirty="0"/>
-              <a:t>- No surface differential geometry (E, F, G, L, M, N).</a:t>
-            </a:r>
-            <a:br>
-              <a:rPr dirty="0"/>
-            </a:br>
-            <a:r>
-              <a:rPr dirty="0"/>
-              <a:t>- No Gaussian/Mean curvature visualization.</a:t>
-            </a:r>
-            <a:br>
-              <a:rPr dirty="0"/>
-            </a:br>
-            <a:r>
-              <a:rPr dirty="0"/>
-              <a:t>- No principal curvature calculations (k₁, k₂).</a:t>
-            </a:r>
-            <a:br>
-              <a:rPr dirty="0"/>
-            </a:br>
-            <a:r>
-              <a:rPr dirty="0"/>
-              <a:t>- Your platform: full differential-geometry suite.</a:t>
-            </a:r>
-          </a:p>
-        </p:txBody>
-      </p:sp>
-    </p:spTree>
-  </p:cSld>
-  <p:clrMapOvr>
-    <a:masterClrMapping/>
-  </p:clrMapOvr>
-</p:sld>
-</file>
-
-<file path=ppt/slides/slide13.xml><?xml version="1.0" encoding="utf-8"?>
-<p:sld xmlns:a="http://schemas.openxmlformats.org/drawingml/2006/main" xmlns:r="http://schemas.openxmlformats.org/officeDocument/2006/relationships" xmlns:p="http://schemas.openxmlformats.org/presentationml/2006/main">
-  <p:cSld>
-    <p:bg>
-      <p:bgPr>
-        <a:solidFill>
-          <a:srgbClr val="1E1E2D"/>
-        </a:solidFill>
-        <a:effectLst/>
-      </p:bgPr>
-    </p:bg>
-    <p:spTree>
-      <p:nvGrpSpPr>
-        <p:cNvPr id="1" name=""/>
-        <p:cNvGrpSpPr/>
-        <p:nvPr/>
-      </p:nvGrpSpPr>
-      <p:grpSpPr>
-        <a:xfrm>
-          <a:off x="0" y="0"/>
-          <a:ext cx="0" cy="0"/>
-          <a:chOff x="0" y="0"/>
-          <a:chExt cx="0" cy="0"/>
-        </a:xfrm>
-      </p:grpSpPr>
-      <p:sp>
-        <p:nvSpPr>
-          <p:cNvPr id="2" name="Title 1"/>
-          <p:cNvSpPr>
-            <a:spLocks noGrp="1"/>
-          </p:cNvSpPr>
-          <p:nvPr>
-            <p:ph type="title"/>
-          </p:nvPr>
-        </p:nvSpPr>
-        <p:spPr/>
-        <p:txBody>
-          <a:bodyPr/>
-          <a:lstStyle/>
-          <a:p>
-            <a:pPr>
-              <a:defRPr sz="4000">
-                <a:solidFill>
-                  <a:srgbClr val="FFFFFF"/>
-                </a:solidFill>
-              </a:defRPr>
-            </a:pPr>
-            <a:r>
-              <a:t>Advanced Advantages</a:t>
-            </a:r>
-          </a:p>
-        </p:txBody>
-      </p:sp>
-      <p:sp>
-        <p:nvSpPr>
-          <p:cNvPr id="4" name="TextBox 3"/>
-          <p:cNvSpPr txBox="1"/>
-          <p:nvPr/>
-        </p:nvSpPr>
-        <p:spPr>
-          <a:xfrm>
-            <a:off x="457200" y="1645920"/>
-            <a:ext cx="8229600" cy="2954655"/>
-          </a:xfrm>
-          <a:prstGeom prst="rect">
-            <a:avLst/>
-          </a:prstGeom>
-          <a:noFill/>
-        </p:spPr>
-        <p:txBody>
-          <a:bodyPr wrap="square">
-            <a:spAutoFit/>
-          </a:bodyPr>
-          <a:lstStyle/>
-          <a:p>
-            <a:endParaRPr dirty="0"/>
-          </a:p>
-          <a:p>
-            <a:pPr>
-              <a:defRPr sz="2400">
-                <a:solidFill>
-                  <a:srgbClr val="FFFFFF"/>
-                </a:solidFill>
-              </a:defRPr>
-            </a:pPr>
-            <a:r>
-              <a:rPr dirty="0"/>
-              <a:t>- Local Python Execution – accuracy guaranteed.</a:t>
-            </a:r>
-            <a:br>
-              <a:rPr dirty="0"/>
-            </a:br>
-            <a:r>
-              <a:rPr dirty="0"/>
-              <a:t>- </a:t>
-            </a:r>
-            <a:r>
-              <a:rPr dirty="0" err="1"/>
-              <a:t>Plotly</a:t>
-            </a:r>
-            <a:r>
-              <a:rPr dirty="0"/>
-              <a:t> WebGL – real 3D rotation and high performance.</a:t>
-            </a:r>
-            <a:br>
-              <a:rPr dirty="0"/>
-            </a:br>
-            <a:r>
-              <a:rPr dirty="0"/>
-              <a:t>- Custom curve/surface input – user types any X(</a:t>
-            </a:r>
-            <a:r>
-              <a:rPr dirty="0" err="1"/>
-              <a:t>u,v</a:t>
-            </a:r>
-            <a:r>
-              <a:rPr dirty="0"/>
-              <a:t>) or r(t).</a:t>
-            </a:r>
-            <a:br>
-              <a:rPr dirty="0"/>
-            </a:br>
-            <a:r>
-              <a:rPr dirty="0"/>
-              <a:t>- Supports educational demonstrations – step-by-step math.</a:t>
-            </a:r>
-            <a:br>
-              <a:rPr dirty="0"/>
-            </a:br>
-            <a:r>
-              <a:rPr dirty="0"/>
-              <a:t>- Research-ready – exact symbolic forms exported as LaTeX.</a:t>
-            </a:r>
-            <a:br>
-              <a:rPr dirty="0"/>
-            </a:br>
-            <a:r>
-              <a:rPr dirty="0"/>
-              <a:t>- Supports extremely complex surfaces – torus, helicoid, paraboloid, etc.</a:t>
-            </a:r>
-          </a:p>
-        </p:txBody>
-      </p:sp>
-    </p:spTree>
-  </p:cSld>
-  <p:clrMapOvr>
-    <a:masterClrMapping/>
-  </p:clrMapOvr>
-</p:sld>
-</file>
-
-<file path=ppt/slides/slide14.xml><?xml version="1.0" encoding="utf-8"?>
-<p:sld xmlns:a="http://schemas.openxmlformats.org/drawingml/2006/main" xmlns:r="http://schemas.openxmlformats.org/officeDocument/2006/relationships" xmlns:p="http://schemas.openxmlformats.org/presentationml/2006/main">
-  <p:cSld>
-    <p:bg>
-      <p:bgPr>
-        <a:solidFill>
-          <a:srgbClr val="1E1E2D"/>
-        </a:solidFill>
-        <a:effectLst/>
-      </p:bgPr>
-    </p:bg>
-    <p:spTree>
-      <p:nvGrpSpPr>
-        <p:cNvPr id="1" name=""/>
-        <p:cNvGrpSpPr/>
-        <p:nvPr/>
-      </p:nvGrpSpPr>
-      <p:grpSpPr>
-        <a:xfrm>
-          <a:off x="0" y="0"/>
-          <a:ext cx="0" cy="0"/>
-          <a:chOff x="0" y="0"/>
-          <a:chExt cx="0" cy="0"/>
-        </a:xfrm>
-      </p:grpSpPr>
-      <p:sp>
-        <p:nvSpPr>
-          <p:cNvPr id="2" name="Title 1"/>
-          <p:cNvSpPr>
-            <a:spLocks noGrp="1"/>
-          </p:cNvSpPr>
-          <p:nvPr>
-            <p:ph type="title"/>
-          </p:nvPr>
-        </p:nvSpPr>
-        <p:spPr/>
-        <p:txBody>
-          <a:bodyPr/>
-          <a:lstStyle/>
-          <a:p>
-            <a:pPr>
-              <a:defRPr sz="4000">
-                <a:solidFill>
-                  <a:srgbClr val="FFFFFF"/>
-                </a:solidFill>
-              </a:defRPr>
-            </a:pPr>
-            <a:r>
-              <a:t>Workflow Advantages</a:t>
-            </a:r>
-          </a:p>
-        </p:txBody>
-      </p:sp>
-      <p:sp>
-        <p:nvSpPr>
-          <p:cNvPr id="4" name="TextBox 3"/>
-          <p:cNvSpPr txBox="1"/>
-          <p:nvPr/>
-        </p:nvSpPr>
-        <p:spPr>
-          <a:xfrm>
-            <a:off x="457200" y="1645920"/>
-            <a:ext cx="8229600" cy="2954655"/>
-          </a:xfrm>
-          <a:prstGeom prst="rect">
-            <a:avLst/>
-          </a:prstGeom>
-          <a:noFill/>
-        </p:spPr>
-        <p:txBody>
-          <a:bodyPr wrap="square">
-            <a:spAutoFit/>
-          </a:bodyPr>
-          <a:lstStyle/>
-          <a:p>
-            <a:endParaRPr dirty="0"/>
-          </a:p>
-          <a:p>
-            <a:pPr>
-              <a:defRPr sz="2400">
-                <a:solidFill>
-                  <a:srgbClr val="FFFFFF"/>
-                </a:solidFill>
-              </a:defRPr>
-            </a:pPr>
-            <a:r>
-              <a:rPr dirty="0"/>
-              <a:t>- 1. User inputs curve/surface.</a:t>
-            </a:r>
-            <a:br>
-              <a:rPr dirty="0"/>
-            </a:br>
-            <a:r>
-              <a:rPr dirty="0"/>
-              <a:t>- 2. Backend computes symbolic derivatives automatically.</a:t>
-            </a:r>
-            <a:br>
-              <a:rPr dirty="0"/>
-            </a:br>
-            <a:r>
-              <a:rPr dirty="0"/>
-              <a:t>- 3. Numerical values generated using NumPy.</a:t>
-            </a:r>
-            <a:br>
-              <a:rPr dirty="0"/>
-            </a:br>
-            <a:r>
-              <a:rPr dirty="0"/>
-              <a:t>- 4. 3D graph rendered with </a:t>
-            </a:r>
-            <a:r>
-              <a:rPr dirty="0" err="1"/>
-              <a:t>Plotly</a:t>
-            </a:r>
-            <a:r>
-              <a:rPr dirty="0"/>
-              <a:t> instantly.</a:t>
-            </a:r>
-            <a:br>
-              <a:rPr dirty="0"/>
-            </a:br>
-            <a:r>
-              <a:rPr dirty="0"/>
-              <a:t>- 5. </a:t>
-            </a:r>
-            <a:r>
-              <a:rPr dirty="0" err="1"/>
-              <a:t>MathJax</a:t>
-            </a:r>
-            <a:r>
-              <a:rPr dirty="0"/>
-              <a:t> renders LaTeX beautifully in the browser.</a:t>
-            </a:r>
-            <a:br>
-              <a:rPr dirty="0"/>
-            </a:br>
-            <a:r>
-              <a:rPr dirty="0"/>
-              <a:t>- No workflow like this exists in Desmos, GeoGebra, or Mathematica.</a:t>
-            </a:r>
-          </a:p>
-        </p:txBody>
-      </p:sp>
-    </p:spTree>
-  </p:cSld>
-  <p:clrMapOvr>
-    <a:masterClrMapping/>
-  </p:clrMapOvr>
-</p:sld>
-</file>
-
-<file path=ppt/slides/slide15.xml><?xml version="1.0" encoding="utf-8"?>
-<p:sld xmlns:a="http://schemas.openxmlformats.org/drawingml/2006/main" xmlns:r="http://schemas.openxmlformats.org/officeDocument/2006/relationships" xmlns:p="http://schemas.openxmlformats.org/presentationml/2006/main">
-  <p:cSld>
-    <p:bg>
-      <p:bgPr>
-        <a:solidFill>
-          <a:srgbClr val="1E1E2D"/>
-        </a:solidFill>
-        <a:effectLst/>
-      </p:bgPr>
-    </p:bg>
-    <p:spTree>
-      <p:nvGrpSpPr>
-        <p:cNvPr id="1" name=""/>
-        <p:cNvGrpSpPr/>
-        <p:nvPr/>
-      </p:nvGrpSpPr>
-      <p:grpSpPr>
-        <a:xfrm>
-          <a:off x="0" y="0"/>
-          <a:ext cx="0" cy="0"/>
-          <a:chOff x="0" y="0"/>
-          <a:chExt cx="0" cy="0"/>
-        </a:xfrm>
-      </p:grpSpPr>
-      <p:sp>
-        <p:nvSpPr>
-          <p:cNvPr id="2" name="Title 1"/>
-          <p:cNvSpPr>
-            <a:spLocks noGrp="1"/>
-          </p:cNvSpPr>
-          <p:nvPr>
-            <p:ph type="title"/>
-          </p:nvPr>
-        </p:nvSpPr>
-        <p:spPr/>
-        <p:txBody>
-          <a:bodyPr/>
-          <a:lstStyle/>
-          <a:p>
-            <a:pPr>
-              <a:defRPr sz="4000">
-                <a:solidFill>
-                  <a:srgbClr val="FFFFFF"/>
-                </a:solidFill>
-              </a:defRPr>
-            </a:pPr>
-            <a:r>
-              <a:t>Real-World Applications</a:t>
-            </a:r>
-          </a:p>
-        </p:txBody>
-      </p:sp>
-      <p:sp>
-        <p:nvSpPr>
-          <p:cNvPr id="4" name="TextBox 3"/>
-          <p:cNvSpPr txBox="1"/>
-          <p:nvPr/>
-        </p:nvSpPr>
-        <p:spPr>
-          <a:xfrm>
-            <a:off x="457200" y="1645920"/>
-            <a:ext cx="8229600" cy="4572000"/>
-          </a:xfrm>
-          <a:prstGeom prst="rect">
-            <a:avLst/>
-          </a:prstGeom>
-          <a:noFill/>
-        </p:spPr>
-        <p:txBody>
-          <a:bodyPr wrap="square">
-            <a:spAutoFit/>
-          </a:bodyPr>
-          <a:lstStyle/>
-          <a:p>
-            <a:endParaRPr/>
-          </a:p>
-          <a:p>
-            <a:pPr>
-              <a:defRPr sz="2400">
-                <a:solidFill>
-                  <a:srgbClr val="FFFFFF"/>
-                </a:solidFill>
-              </a:defRPr>
-            </a:pPr>
-            <a:r>
-              <a:t>- Engineering: beam bending curves (κ), torsion stresses (τ).</a:t>
-            </a:r>
-            <a:br/>
-            <a:r>
-              <a:t>- Robotics: path curvature for manipulators.</a:t>
-            </a:r>
-            <a:br/>
-            <a:r>
-              <a:t>- Computer graphics: surface normals &amp; curvature for shading.</a:t>
-            </a:r>
-            <a:br/>
-            <a:r>
-              <a:t>- Physics: geodesics on curved surfaces, minimal surfaces.</a:t>
-            </a:r>
-            <a:br/>
-            <a:r>
-              <a:t>- Mathematics: teaching differential geometry visualizations.</a:t>
-            </a:r>
-            <a:br/>
-            <a:r>
-              <a:t>- Architecture: toroidal &amp; curved structural surfaces.</a:t>
-            </a:r>
-          </a:p>
-        </p:txBody>
-      </p:sp>
-    </p:spTree>
-  </p:cSld>
-  <p:clrMapOvr>
-    <a:masterClrMapping/>
-  </p:clrMapOvr>
-</p:sld>
-</file>
-
-<file path=ppt/slides/slide16.xml><?xml version="1.0" encoding="utf-8"?>
-<p:sld xmlns:a="http://schemas.openxmlformats.org/drawingml/2006/main" xmlns:r="http://schemas.openxmlformats.org/officeDocument/2006/relationships" xmlns:p="http://schemas.openxmlformats.org/presentationml/2006/main">
-  <p:cSld>
-    <p:bg>
-      <p:bgPr>
-        <a:solidFill>
-          <a:srgbClr val="1E1E2D"/>
-        </a:solidFill>
-        <a:effectLst/>
-      </p:bgPr>
-    </p:bg>
-    <p:spTree>
-      <p:nvGrpSpPr>
-        <p:cNvPr id="1" name=""/>
-        <p:cNvGrpSpPr/>
-        <p:nvPr/>
-      </p:nvGrpSpPr>
-      <p:grpSpPr>
-        <a:xfrm>
-          <a:off x="0" y="0"/>
-          <a:ext cx="0" cy="0"/>
-          <a:chOff x="0" y="0"/>
-          <a:chExt cx="0" cy="0"/>
-        </a:xfrm>
-      </p:grpSpPr>
-      <p:sp>
-        <p:nvSpPr>
-          <p:cNvPr id="2" name="Title 1"/>
-          <p:cNvSpPr>
-            <a:spLocks noGrp="1"/>
-          </p:cNvSpPr>
-          <p:nvPr>
-            <p:ph type="title"/>
-          </p:nvPr>
-        </p:nvSpPr>
-        <p:spPr/>
-        <p:txBody>
-          <a:bodyPr/>
-          <a:lstStyle/>
-          <a:p>
-            <a:pPr>
-              <a:defRPr sz="4000">
-                <a:solidFill>
-                  <a:srgbClr val="FFFFFF"/>
-                </a:solidFill>
-              </a:defRPr>
-            </a:pPr>
-            <a:r>
-              <a:rPr dirty="0"/>
-              <a:t>User Guide – How to Use the Interface</a:t>
-            </a:r>
-          </a:p>
-        </p:txBody>
-      </p:sp>
-      <p:sp>
-        <p:nvSpPr>
-          <p:cNvPr id="4" name="TextBox 3"/>
-          <p:cNvSpPr txBox="1"/>
-          <p:nvPr/>
-        </p:nvSpPr>
-        <p:spPr>
-          <a:xfrm>
-            <a:off x="640080" y="1341120"/>
-            <a:ext cx="7315200" cy="4572000"/>
-          </a:xfrm>
-          <a:prstGeom prst="rect">
-            <a:avLst/>
-          </a:prstGeom>
-          <a:noFill/>
-        </p:spPr>
-        <p:txBody>
-          <a:bodyPr wrap="square">
-            <a:spAutoFit/>
-          </a:bodyPr>
-          <a:lstStyle/>
-          <a:p>
-            <a:endParaRPr dirty="0"/>
-          </a:p>
-          <a:p>
-            <a:pPr>
-              <a:defRPr sz="2400">
-                <a:solidFill>
-                  <a:srgbClr val="FFFFFF"/>
-                </a:solidFill>
-              </a:defRPr>
-            </a:pPr>
-            <a:r>
-              <a:rPr dirty="0"/>
-              <a:t>1. Select Mode (Curve / Surface)</a:t>
-            </a:r>
-            <a:br>
-              <a:rPr dirty="0"/>
-            </a:br>
-            <a:r>
-              <a:rPr dirty="0"/>
-              <a:t>2. Choose a curve or surface from the dropdown</a:t>
-            </a:r>
-            <a:br>
-              <a:rPr dirty="0"/>
-            </a:br>
-            <a:r>
-              <a:rPr dirty="0"/>
-              <a:t>3. Adjust parameters (a, b, ranges, resolution)</a:t>
-            </a:r>
-            <a:br>
-              <a:rPr dirty="0"/>
-            </a:br>
-            <a:r>
-              <a:rPr dirty="0"/>
-              <a:t>4. Choose a quantity (e.g., curvature, fundamental forms)</a:t>
-            </a:r>
-            <a:br>
-              <a:rPr dirty="0"/>
-            </a:br>
-            <a:r>
-              <a:rPr dirty="0"/>
-              <a:t>5. For symbolic surface calculations, check 'Compute Symbolic'</a:t>
-            </a:r>
-            <a:br>
-              <a:rPr dirty="0"/>
-            </a:br>
-            <a:r>
-              <a:rPr dirty="0"/>
-              <a:t>6. Press 'Compute &amp; Plot'</a:t>
-            </a:r>
-            <a:br>
-              <a:rPr dirty="0"/>
-            </a:br>
-            <a:br>
-              <a:rPr dirty="0"/>
-            </a:br>
-            <a:r>
-              <a:rPr dirty="0"/>
-              <a:t>Results displayed:</a:t>
-            </a:r>
-            <a:br>
-              <a:rPr dirty="0"/>
-            </a:br>
-            <a:r>
-              <a:rPr dirty="0"/>
-              <a:t>- Interactive </a:t>
-            </a:r>
-            <a:r>
-              <a:rPr dirty="0" err="1"/>
-              <a:t>Plotly</a:t>
-            </a:r>
-            <a:r>
-              <a:rPr dirty="0"/>
-              <a:t> graph</a:t>
-            </a:r>
-            <a:br>
-              <a:rPr dirty="0"/>
-            </a:br>
-            <a:r>
-              <a:rPr dirty="0"/>
-              <a:t>- Numerical table data</a:t>
-            </a:r>
-            <a:br>
-              <a:rPr dirty="0"/>
-            </a:br>
-            <a:r>
-              <a:rPr dirty="0"/>
-              <a:t>- Symbolic LaTeX-rendered formulas (</a:t>
-            </a:r>
-            <a:r>
-              <a:rPr dirty="0" err="1"/>
-              <a:t>MathJax</a:t>
-            </a:r>
-            <a:r>
-              <a:rPr dirty="0"/>
-              <a:t>)</a:t>
-            </a:r>
-          </a:p>
-        </p:txBody>
-      </p:sp>
-    </p:spTree>
-  </p:cSld>
-  <p:clrMapOvr>
-    <a:masterClrMapping/>
-  </p:clrMapOvr>
-</p:sld>
-</file>
-
-<file path=ppt/slides/slide17.xml><?xml version="1.0" encoding="utf-8"?>
-<p:sld xmlns:a="http://schemas.openxmlformats.org/drawingml/2006/main" xmlns:r="http://schemas.openxmlformats.org/officeDocument/2006/relationships" xmlns:p="http://schemas.openxmlformats.org/presentationml/2006/main">
-  <p:cSld>
-    <p:bg>
-      <p:bgPr>
-        <a:solidFill>
-          <a:srgbClr val="1E1E2D"/>
-        </a:solidFill>
-        <a:effectLst/>
-      </p:bgPr>
-    </p:bg>
-    <p:spTree>
-      <p:nvGrpSpPr>
-        <p:cNvPr id="1" name=""/>
-        <p:cNvGrpSpPr/>
-        <p:nvPr/>
-      </p:nvGrpSpPr>
-      <p:grpSpPr>
-        <a:xfrm>
-          <a:off x="0" y="0"/>
-          <a:ext cx="0" cy="0"/>
-          <a:chOff x="0" y="0"/>
-          <a:chExt cx="0" cy="0"/>
-        </a:xfrm>
-      </p:grpSpPr>
-      <p:sp>
-        <p:nvSpPr>
-          <p:cNvPr id="2" name="Title 1"/>
-          <p:cNvSpPr>
-            <a:spLocks noGrp="1"/>
-          </p:cNvSpPr>
-          <p:nvPr>
-            <p:ph type="title"/>
-          </p:nvPr>
-        </p:nvSpPr>
-        <p:spPr/>
-        <p:txBody>
-          <a:bodyPr/>
-          <a:lstStyle/>
-          <a:p>
-            <a:pPr>
-              <a:defRPr sz="4000">
-                <a:solidFill>
-                  <a:srgbClr val="FFFFFF"/>
-                </a:solidFill>
-              </a:defRPr>
-            </a:pPr>
-            <a:r>
-              <a:rPr dirty="0"/>
-              <a:t>Behind the Scenes – Code Architecture</a:t>
-            </a:r>
-          </a:p>
-        </p:txBody>
-      </p:sp>
-      <p:sp>
-        <p:nvSpPr>
-          <p:cNvPr id="4" name="TextBox 3"/>
-          <p:cNvSpPr txBox="1"/>
-          <p:nvPr/>
-        </p:nvSpPr>
-        <p:spPr>
-          <a:xfrm>
-            <a:off x="640080" y="1016656"/>
-            <a:ext cx="7315200" cy="4572000"/>
-          </a:xfrm>
-          <a:prstGeom prst="rect">
-            <a:avLst/>
-          </a:prstGeom>
-          <a:noFill/>
-        </p:spPr>
-        <p:txBody>
-          <a:bodyPr wrap="square">
-            <a:spAutoFit/>
-          </a:bodyPr>
-          <a:lstStyle/>
-          <a:p>
-            <a:endParaRPr dirty="0"/>
-          </a:p>
-          <a:p>
-            <a:pPr>
-              <a:defRPr sz="2400">
-                <a:solidFill>
-                  <a:srgbClr val="FFFFFF"/>
-                </a:solidFill>
-              </a:defRPr>
-            </a:pPr>
-            <a:r>
-              <a:rPr dirty="0"/>
-              <a:t>Frontend (Browser):</a:t>
-            </a:r>
-            <a:br>
-              <a:rPr dirty="0"/>
-            </a:br>
-            <a:r>
-              <a:rPr dirty="0"/>
-              <a:t>- HTML/CSS interface</a:t>
-            </a:r>
-            <a:br>
-              <a:rPr dirty="0"/>
-            </a:br>
-            <a:r>
-              <a:rPr dirty="0"/>
-              <a:t>- JavaScript (script.js) sends AJAX requests</a:t>
-            </a:r>
-            <a:br>
-              <a:rPr dirty="0"/>
-            </a:br>
-            <a:r>
-              <a:rPr dirty="0"/>
-              <a:t>- </a:t>
-            </a:r>
-            <a:r>
-              <a:rPr dirty="0" err="1"/>
-              <a:t>Plotly</a:t>
-            </a:r>
-            <a:r>
-              <a:rPr dirty="0"/>
-              <a:t> renders 2D/3D graphs</a:t>
-            </a:r>
-            <a:br>
-              <a:rPr dirty="0"/>
-            </a:br>
-            <a:br>
-              <a:rPr dirty="0"/>
-            </a:br>
-            <a:r>
-              <a:rPr dirty="0"/>
-              <a:t>Backend (Django):</a:t>
-            </a:r>
-            <a:br>
-              <a:rPr dirty="0"/>
-            </a:br>
-            <a:r>
-              <a:rPr dirty="0"/>
-              <a:t>- views.py handles /compute/ requests</a:t>
-            </a:r>
-            <a:br>
-              <a:rPr dirty="0"/>
-            </a:br>
-            <a:r>
-              <a:rPr dirty="0"/>
-              <a:t>- utils.py performs symbolic &amp; numeric math</a:t>
-            </a:r>
-            <a:br>
-              <a:rPr dirty="0"/>
-            </a:br>
-            <a:r>
-              <a:rPr dirty="0"/>
-              <a:t>- </a:t>
-            </a:r>
-            <a:r>
-              <a:rPr dirty="0" err="1"/>
-              <a:t>SymPy</a:t>
-            </a:r>
-            <a:r>
-              <a:rPr dirty="0"/>
-              <a:t> = symbolic derivatives, curvature, forms</a:t>
-            </a:r>
-            <a:br>
-              <a:rPr dirty="0"/>
-            </a:br>
-            <a:r>
-              <a:rPr dirty="0"/>
-              <a:t>- NumPy = fast numerical evaluation</a:t>
-            </a:r>
-            <a:br>
-              <a:rPr dirty="0"/>
-            </a:br>
-            <a:br>
-              <a:rPr dirty="0"/>
-            </a:br>
-            <a:r>
-              <a:rPr dirty="0"/>
-              <a:t>Result Pipeline:</a:t>
-            </a:r>
-            <a:br>
-              <a:rPr dirty="0"/>
-            </a:br>
-            <a:r>
-              <a:rPr dirty="0"/>
-              <a:t>User → JS → Django → </a:t>
-            </a:r>
-            <a:r>
-              <a:rPr dirty="0" err="1"/>
-              <a:t>SymPy</a:t>
-            </a:r>
-            <a:r>
-              <a:rPr dirty="0"/>
-              <a:t>/NumPy → JSON → </a:t>
-            </a:r>
-            <a:r>
-              <a:rPr dirty="0" err="1"/>
-              <a:t>Plotly</a:t>
-            </a:r>
-            <a:r>
-              <a:rPr dirty="0"/>
-              <a:t>/</a:t>
-            </a:r>
-            <a:r>
-              <a:rPr dirty="0" err="1"/>
-              <a:t>MathJax</a:t>
-            </a:r>
-            <a:r>
-              <a:rPr dirty="0"/>
-              <a:t> → User</a:t>
-            </a:r>
-          </a:p>
-        </p:txBody>
-      </p:sp>
-    </p:spTree>
-  </p:cSld>
-  <p:clrMapOvr>
-    <a:masterClrMapping/>
-  </p:clrMapOvr>
-</p:sld>
-</file>
-
-<file path=ppt/slides/slide18.xml><?xml version="1.0" encoding="utf-8"?>
-<p:sld xmlns:a="http://schemas.openxmlformats.org/drawingml/2006/main" xmlns:r="http://schemas.openxmlformats.org/officeDocument/2006/relationships" xmlns:p="http://schemas.openxmlformats.org/presentationml/2006/main">
-  <p:cSld>
-    <p:bg>
-      <p:bgPr>
-        <a:solidFill>
-          <a:srgbClr val="1E1E2D"/>
-        </a:solidFill>
-        <a:effectLst/>
-      </p:bgPr>
-    </p:bg>
-    <p:spTree>
-      <p:nvGrpSpPr>
-        <p:cNvPr id="1" name=""/>
-        <p:cNvGrpSpPr/>
-        <p:nvPr/>
-      </p:nvGrpSpPr>
-      <p:grpSpPr>
-        <a:xfrm>
-          <a:off x="0" y="0"/>
-          <a:ext cx="0" cy="0"/>
-          <a:chOff x="0" y="0"/>
-          <a:chExt cx="0" cy="0"/>
-        </a:xfrm>
-      </p:grpSpPr>
-      <p:sp>
-        <p:nvSpPr>
-          <p:cNvPr id="2" name="Title 1"/>
-          <p:cNvSpPr>
-            <a:spLocks noGrp="1"/>
-          </p:cNvSpPr>
-          <p:nvPr>
-            <p:ph type="title"/>
-          </p:nvPr>
-        </p:nvSpPr>
-        <p:spPr/>
-        <p:txBody>
-          <a:bodyPr/>
-          <a:lstStyle/>
-          <a:p>
-            <a:pPr>
-              <a:defRPr sz="4000">
-                <a:solidFill>
-                  <a:srgbClr val="FFFFFF"/>
-                </a:solidFill>
-              </a:defRPr>
-            </a:pPr>
-            <a:r>
-              <a:t>Future Work &amp; Improvements</a:t>
-            </a:r>
-          </a:p>
-        </p:txBody>
-      </p:sp>
-      <p:sp>
-        <p:nvSpPr>
-          <p:cNvPr id="4" name="TextBox 3"/>
-          <p:cNvSpPr txBox="1"/>
-          <p:nvPr/>
-        </p:nvSpPr>
-        <p:spPr>
-          <a:xfrm>
-            <a:off x="640080" y="1417638"/>
-            <a:ext cx="7315200" cy="4572000"/>
-          </a:xfrm>
-          <a:prstGeom prst="rect">
-            <a:avLst/>
-          </a:prstGeom>
-          <a:noFill/>
-        </p:spPr>
-        <p:txBody>
-          <a:bodyPr wrap="square">
-            <a:spAutoFit/>
-          </a:bodyPr>
-          <a:lstStyle/>
-          <a:p>
-            <a:endParaRPr dirty="0"/>
-          </a:p>
-          <a:p>
-            <a:pPr>
-              <a:defRPr sz="2400">
-                <a:solidFill>
-                  <a:srgbClr val="FFFFFF"/>
-                </a:solidFill>
-              </a:defRPr>
-            </a:pPr>
-            <a:r>
-              <a:rPr dirty="0"/>
-              <a:t>- Add geodesics computation for surface curves</a:t>
-            </a:r>
-            <a:br>
-              <a:rPr dirty="0"/>
-            </a:br>
-            <a:r>
-              <a:rPr dirty="0"/>
-              <a:t>- Add heatmaps for curvature on surfaces</a:t>
-            </a:r>
-            <a:br>
-              <a:rPr dirty="0"/>
-            </a:br>
-            <a:r>
-              <a:rPr dirty="0"/>
-              <a:t>- Add export options (PDF, PNG, CSV, symbolic)</a:t>
-            </a:r>
-            <a:br>
-              <a:rPr dirty="0"/>
-            </a:br>
-            <a:r>
-              <a:rPr dirty="0"/>
-              <a:t>- Add animation mode (moving point along curve)</a:t>
-            </a:r>
-            <a:br>
-              <a:rPr dirty="0"/>
-            </a:br>
-            <a:r>
-              <a:rPr dirty="0"/>
-              <a:t>- Add 4D hypersurface support</a:t>
-            </a:r>
-            <a:br>
-              <a:rPr dirty="0"/>
-            </a:br>
-            <a:r>
-              <a:rPr dirty="0"/>
-              <a:t>- Optimize symbolic computations for heavy surfaces</a:t>
-            </a:r>
-            <a:br>
-              <a:rPr dirty="0"/>
-            </a:br>
-            <a:r>
-              <a:rPr dirty="0"/>
-              <a:t>- Add mobile-friendly responsive UI</a:t>
-            </a:r>
-            <a:br>
-              <a:rPr dirty="0"/>
-            </a:br>
-            <a:r>
-              <a:rPr dirty="0"/>
-              <a:t>- Add saving/loading user custom equations</a:t>
-            </a:r>
           </a:p>
         </p:txBody>
       </p:sp>
@@ -4961,8 +3581,8 @@
         </p:nvSpPr>
         <p:spPr>
           <a:xfrm>
-            <a:off x="914400" y="1828800"/>
-            <a:ext cx="7315200" cy="3657600"/>
+            <a:off x="914400" y="1043384"/>
+            <a:ext cx="7315200" cy="5539978"/>
           </a:xfrm>
           <a:prstGeom prst="rect">
             <a:avLst/>
@@ -4975,7 +3595,7 @@
           </a:bodyPr>
           <a:lstStyle/>
           <a:p>
-            <a:endParaRPr/>
+            <a:endParaRPr dirty="0"/>
           </a:p>
           <a:p>
             <a:pPr>
@@ -4986,27 +3606,185 @@
               </a:defRPr>
             </a:pPr>
             <a:r>
+              <a:rPr dirty="0"/>
               <a:t>- Plots high-resolution 2D/3D curves and surfaces</a:t>
             </a:r>
-            <a:br/>
-            <a:r>
-              <a:t>- Computes curvature, torsion, Frenet–Serret frame</a:t>
-            </a:r>
-            <a:br/>
-            <a:r>
-              <a:t>- Computes First/Second Fundamental Forms</a:t>
-            </a:r>
-            <a:br/>
-            <a:r>
-              <a:t>- Computes Gaussian/Mean curvature &amp; Christoffel symbols</a:t>
-            </a:r>
-            <a:br/>
-            <a:r>
-              <a:t>- Uses SymPy, NumPy, Plotly, Django</a:t>
-            </a:r>
-            <a:br/>
-            <a:r>
-              <a:t>- Full transparency &amp; modifiable code</a:t>
+            <a:endParaRPr lang="en-CA" dirty="0"/>
+          </a:p>
+          <a:p>
+            <a:pPr>
+              <a:defRPr sz="2400">
+                <a:solidFill>
+                  <a:srgbClr val="FFFFFF"/>
+                </a:solidFill>
+              </a:defRPr>
+            </a:pPr>
+            <a:r>
+              <a:rPr lang="en-CA" dirty="0"/>
+              <a:t>- Computational support for:</a:t>
+            </a:r>
+          </a:p>
+          <a:p>
+            <a:pPr lvl="1">
+              <a:defRPr sz="2400">
+                <a:solidFill>
+                  <a:srgbClr val="FFFFFF"/>
+                </a:solidFill>
+              </a:defRPr>
+            </a:pPr>
+            <a:r>
+              <a:rPr lang="en-CA" dirty="0"/>
+              <a:t>- Arc length</a:t>
+            </a:r>
+            <a:br>
+              <a:rPr dirty="0"/>
+            </a:br>
+            <a:r>
+              <a:rPr lang="en-CA" dirty="0"/>
+              <a:t>- Arc length </a:t>
+            </a:r>
+            <a:r>
+              <a:rPr lang="en-CA" dirty="0" err="1"/>
+              <a:t>reparametrization</a:t>
+            </a:r>
+            <a:endParaRPr lang="en-CA" dirty="0"/>
+          </a:p>
+          <a:p>
+            <a:pPr lvl="1">
+              <a:defRPr sz="2400">
+                <a:solidFill>
+                  <a:srgbClr val="FFFFFF"/>
+                </a:solidFill>
+              </a:defRPr>
+            </a:pPr>
+            <a:r>
+              <a:rPr lang="en-CA" dirty="0"/>
+              <a:t>- </a:t>
+            </a:r>
+            <a:r>
+              <a:rPr lang="en-CA" dirty="0" err="1"/>
+              <a:t>Frenet</a:t>
+            </a:r>
+            <a:r>
+              <a:rPr lang="en-CA" dirty="0"/>
+              <a:t>-Serret apparatus, with curvature and torsion</a:t>
+            </a:r>
+          </a:p>
+          <a:p>
+            <a:pPr lvl="1">
+              <a:defRPr sz="2400">
+                <a:solidFill>
+                  <a:srgbClr val="FFFFFF"/>
+                </a:solidFill>
+              </a:defRPr>
+            </a:pPr>
+            <a:r>
+              <a:rPr lang="en-CA" dirty="0"/>
+              <a:t>- First Fundamental Form</a:t>
+            </a:r>
+          </a:p>
+          <a:p>
+            <a:pPr lvl="1">
+              <a:defRPr sz="2400">
+                <a:solidFill>
+                  <a:srgbClr val="FFFFFF"/>
+                </a:solidFill>
+              </a:defRPr>
+            </a:pPr>
+            <a:r>
+              <a:rPr lang="en-CA" dirty="0"/>
+              <a:t>- Surface area</a:t>
+            </a:r>
+          </a:p>
+          <a:p>
+            <a:pPr lvl="1">
+              <a:defRPr sz="2400">
+                <a:solidFill>
+                  <a:srgbClr val="FFFFFF"/>
+                </a:solidFill>
+              </a:defRPr>
+            </a:pPr>
+            <a:r>
+              <a:rPr lang="en-CA" dirty="0"/>
+              <a:t>- Second Fundamental Form</a:t>
+            </a:r>
+          </a:p>
+          <a:p>
+            <a:pPr lvl="1">
+              <a:defRPr sz="2400">
+                <a:solidFill>
+                  <a:srgbClr val="FFFFFF"/>
+                </a:solidFill>
+              </a:defRPr>
+            </a:pPr>
+            <a:r>
+              <a:rPr lang="en-CA" dirty="0"/>
+              <a:t>- Shape operator</a:t>
+            </a:r>
+          </a:p>
+          <a:p>
+            <a:pPr lvl="1">
+              <a:defRPr sz="2400">
+                <a:solidFill>
+                  <a:srgbClr val="FFFFFF"/>
+                </a:solidFill>
+              </a:defRPr>
+            </a:pPr>
+            <a:r>
+              <a:rPr lang="en-CA" dirty="0"/>
+              <a:t>- Mean curvature</a:t>
+            </a:r>
+          </a:p>
+          <a:p>
+            <a:pPr lvl="1">
+              <a:defRPr sz="2400">
+                <a:solidFill>
+                  <a:srgbClr val="FFFFFF"/>
+                </a:solidFill>
+              </a:defRPr>
+            </a:pPr>
+            <a:r>
+              <a:rPr lang="en-CA" dirty="0"/>
+              <a:t>- Gaussian curvature</a:t>
+            </a:r>
+          </a:p>
+          <a:p>
+            <a:pPr lvl="1">
+              <a:defRPr sz="2400">
+                <a:solidFill>
+                  <a:srgbClr val="FFFFFF"/>
+                </a:solidFill>
+              </a:defRPr>
+            </a:pPr>
+            <a:r>
+              <a:rPr lang="en-CA" dirty="0"/>
+              <a:t>- Christoffel symbols</a:t>
+            </a:r>
+          </a:p>
+          <a:p>
+            <a:pPr lvl="1">
+              <a:defRPr sz="2400">
+                <a:solidFill>
+                  <a:srgbClr val="FFFFFF"/>
+                </a:solidFill>
+              </a:defRPr>
+            </a:pPr>
+            <a:r>
+              <a:rPr lang="en-CA" dirty="0"/>
+              <a:t>- Codazzi equations</a:t>
+            </a:r>
+          </a:p>
+          <a:p>
+            <a:pPr lvl="1">
+              <a:defRPr sz="2400">
+                <a:solidFill>
+                  <a:srgbClr val="FFFFFF"/>
+                </a:solidFill>
+              </a:defRPr>
+            </a:pPr>
+            <a:r>
+              <a:rPr lang="en-CA" dirty="0"/>
+              <a:t>- Gauss equations</a:t>
             </a:r>
           </a:p>
         </p:txBody>
@@ -5056,7 +3834,9 @@
         </p:nvSpPr>
         <p:spPr/>
         <p:txBody>
-          <a:bodyPr/>
+          <a:bodyPr>
+            <a:normAutofit/>
+          </a:bodyPr>
           <a:lstStyle/>
           <a:p>
             <a:pPr>
@@ -5067,8 +3847,12 @@
               </a:defRPr>
             </a:pPr>
             <a:r>
-              <a:rPr dirty="0"/>
-              <a:t>Why Better Than Mathematica &amp; Online Tools</a:t>
+              <a:rPr lang="en-CA" dirty="0"/>
+              <a:t>Advantages Over </a:t>
+            </a:r>
+            <a:r>
+              <a:rPr dirty="0"/>
+              <a:t>Online Tools</a:t>
             </a:r>
           </a:p>
         </p:txBody>
@@ -5082,7 +3866,7 @@
         <p:spPr>
           <a:xfrm>
             <a:off x="914400" y="1828800"/>
-            <a:ext cx="7315200" cy="3657600"/>
+            <a:ext cx="7315200" cy="2215991"/>
           </a:xfrm>
           <a:prstGeom prst="rect">
             <a:avLst/>
@@ -5095,7 +3879,7 @@
           </a:bodyPr>
           <a:lstStyle/>
           <a:p>
-            <a:endParaRPr/>
+            <a:endParaRPr dirty="0"/>
           </a:p>
           <a:p>
             <a:pPr>
@@ -5106,28 +3890,54 @@
               </a:defRPr>
             </a:pPr>
             <a:r>
-              <a:t>- Free, open-source, local Python computation</a:t>
-            </a:r>
-            <a:br/>
-            <a:r>
-              <a:t>- Real symbolic manipulation using SymPy</a:t>
-            </a:r>
-            <a:br/>
-            <a:r>
-              <a:t>- Fully customizable functions &amp; UI</a:t>
-            </a:r>
-            <a:br/>
-            <a:r>
-              <a:t>- 3D graphs rendered with Plotly WebGL</a:t>
-            </a:r>
-            <a:br/>
-            <a:r>
-              <a:t>- Online graphers cannot compute symbolic curvature</a:t>
-            </a:r>
-            <a:br/>
-            <a:r>
-              <a:t>- Mathematica is closed-source &amp; license-restricted</a:t>
-            </a:r>
+              <a:rPr dirty="0"/>
+              <a:t>- Free, open-source</a:t>
+            </a:r>
+            <a:endParaRPr lang="en-CA" dirty="0"/>
+          </a:p>
+          <a:p>
+            <a:pPr>
+              <a:defRPr sz="2400">
+                <a:solidFill>
+                  <a:srgbClr val="FFFFFF"/>
+                </a:solidFill>
+              </a:defRPr>
+            </a:pPr>
+            <a:r>
+              <a:rPr lang="en-CA" dirty="0"/>
+              <a:t>- Runs in browser, no account or license needed</a:t>
+            </a:r>
+            <a:br>
+              <a:rPr lang="en-CA" dirty="0"/>
+            </a:br>
+            <a:r>
+              <a:rPr dirty="0"/>
+              <a:t>- 3D graphs rendered with </a:t>
+            </a:r>
+            <a:r>
+              <a:rPr dirty="0" err="1"/>
+              <a:t>Plotly</a:t>
+            </a:r>
+            <a:r>
+              <a:rPr dirty="0"/>
+              <a:t> WebGL</a:t>
+            </a:r>
+            <a:r>
+              <a:rPr lang="en-CA" dirty="0"/>
+              <a:t>, which is very lightweight compared to Mathematica</a:t>
+            </a:r>
+            <a:br>
+              <a:rPr dirty="0"/>
+            </a:br>
+            <a:r>
+              <a:rPr dirty="0"/>
+              <a:t>- </a:t>
+            </a:r>
+            <a:r>
+              <a:rPr lang="en-CA" dirty="0"/>
+              <a:t>User-friendly, no need to learn Wolfram Language</a:t>
+            </a:r>
+            <a:endParaRPr dirty="0"/>
           </a:p>
         </p:txBody>
       </p:sp>
@@ -5180,14 +3990,15 @@
           <a:lstStyle/>
           <a:p>
             <a:pPr>
-              <a:defRPr sz="4400">
+              <a:defRPr sz="4000">
                 <a:solidFill>
                   <a:srgbClr val="FFFFFF"/>
                 </a:solidFill>
               </a:defRPr>
             </a:pPr>
             <a:r>
-              <a:t>Python Code Example – Frenet–Serret</a:t>
+              <a:rPr dirty="0"/>
+              <a:t>Code Architecture</a:t>
             </a:r>
           </a:p>
         </p:txBody>
@@ -5200,8 +4011,8 @@
         </p:nvSpPr>
         <p:spPr>
           <a:xfrm>
-            <a:off x="457200" y="1645920"/>
-            <a:ext cx="8229600" cy="4572000"/>
+            <a:off x="640080" y="1016656"/>
+            <a:ext cx="7315200" cy="5539978"/>
           </a:xfrm>
           <a:prstGeom prst="rect">
             <a:avLst/>
@@ -5214,39 +4025,155 @@
           </a:bodyPr>
           <a:lstStyle/>
           <a:p>
-            <a:endParaRPr/>
+            <a:endParaRPr dirty="0"/>
           </a:p>
           <a:p>
             <a:pPr>
-              <a:defRPr sz="2200">
+              <a:defRPr sz="2400">
                 <a:solidFill>
                   <a:srgbClr val="FFFFFF"/>
                 </a:solidFill>
               </a:defRPr>
             </a:pPr>
             <a:r>
-              <a:t>Frenet–Serret Computation:</a:t>
-            </a:r>
-            <a:br/>
-            <a:br/>
-            <a:r>
-              <a:t>T = r'(t) / |r'(t)|</a:t>
-            </a:r>
-            <a:br/>
-            <a:r>
-              <a:t>N = T'(t) / |T'(t)|</a:t>
-            </a:r>
-            <a:br/>
-            <a:r>
-              <a:t>B = T × N</a:t>
-            </a:r>
-            <a:br/>
-            <a:r>
-              <a:t>κ = |r' × r''| / |r'|³</a:t>
-            </a:r>
-            <a:br/>
-            <a:r>
-              <a:t>τ = ((r' × r'') · r''') / |r' × r''|²</a:t>
+              <a:rPr dirty="0"/>
+              <a:t>Frontend (Browser):</a:t>
+            </a:r>
+            <a:br>
+              <a:rPr dirty="0"/>
+            </a:br>
+            <a:r>
+              <a:rPr dirty="0"/>
+              <a:t>- HTML/CSS interface</a:t>
+            </a:r>
+            <a:br>
+              <a:rPr dirty="0"/>
+            </a:br>
+            <a:r>
+              <a:rPr dirty="0"/>
+              <a:t>- JavaScript (script.js) sends AJAX requests</a:t>
+            </a:r>
+            <a:br>
+              <a:rPr dirty="0"/>
+            </a:br>
+            <a:r>
+              <a:rPr dirty="0"/>
+              <a:t>- </a:t>
+            </a:r>
+            <a:r>
+              <a:rPr dirty="0" err="1"/>
+              <a:t>Plotly</a:t>
+            </a:r>
+            <a:r>
+              <a:rPr dirty="0"/>
+              <a:t> renders 2D/3D graphs</a:t>
+            </a:r>
+            <a:br>
+              <a:rPr dirty="0"/>
+            </a:br>
+            <a:br>
+              <a:rPr dirty="0"/>
+            </a:br>
+            <a:r>
+              <a:rPr dirty="0"/>
+              <a:t>Backend (Django):</a:t>
+            </a:r>
+            <a:br>
+              <a:rPr dirty="0"/>
+            </a:br>
+            <a:r>
+              <a:rPr dirty="0"/>
+              <a:t>- views.py </a:t>
+            </a:r>
+            <a:r>
+              <a:rPr lang="en-CA" dirty="0"/>
+              <a:t>handles </a:t>
+            </a:r>
+            <a:r>
+              <a:rPr dirty="0"/>
+              <a:t>requests</a:t>
+            </a:r>
+            <a:br>
+              <a:rPr dirty="0"/>
+            </a:br>
+            <a:r>
+              <a:rPr dirty="0"/>
+              <a:t>- </a:t>
+            </a:r>
+            <a:r>
+              <a:rPr lang="en-CA" dirty="0"/>
+              <a:t>functions</a:t>
+            </a:r>
+            <a:r>
+              <a:rPr dirty="0"/>
+              <a:t>.py performs </a:t>
+            </a:r>
+            <a:r>
+              <a:rPr lang="en-CA" dirty="0"/>
+              <a:t>computations using </a:t>
+            </a:r>
+            <a:r>
+              <a:rPr lang="en-CA" dirty="0" err="1"/>
+              <a:t>SymPy</a:t>
+            </a:r>
+            <a:endParaRPr lang="en-CA" dirty="0"/>
+          </a:p>
+          <a:p>
+            <a:pPr>
+              <a:defRPr sz="2400">
+                <a:solidFill>
+                  <a:srgbClr val="FFFFFF"/>
+                </a:solidFill>
+              </a:defRPr>
+            </a:pPr>
+            <a:r>
+              <a:rPr lang="en-CA" dirty="0"/>
+              <a:t>- Functions tested with 211 different test cases (yes they all pass)</a:t>
+            </a:r>
+            <a:br>
+              <a:rPr dirty="0"/>
+            </a:br>
+            <a:br>
+              <a:rPr dirty="0"/>
+            </a:br>
+            <a:r>
+              <a:rPr lang="en-CA" dirty="0"/>
+              <a:t>User Interaction </a:t>
+            </a:r>
+            <a:r>
+              <a:rPr dirty="0"/>
+              <a:t>Pipeline:</a:t>
+            </a:r>
+            <a:br>
+              <a:rPr dirty="0"/>
+            </a:br>
+            <a:r>
+              <a:rPr dirty="0"/>
+              <a:t>User → JS → Django → </a:t>
+            </a:r>
+            <a:r>
+              <a:rPr dirty="0" err="1"/>
+              <a:t>SymPy</a:t>
+            </a:r>
+            <a:r>
+              <a:rPr dirty="0"/>
+              <a:t>/NumPy → JSON → </a:t>
+            </a:r>
+            <a:r>
+              <a:rPr dirty="0" err="1"/>
+              <a:t>Plotly</a:t>
+            </a:r>
+            <a:r>
+              <a:rPr dirty="0"/>
+              <a:t>/</a:t>
+            </a:r>
+            <a:r>
+              <a:rPr dirty="0" err="1"/>
+              <a:t>MathJax</a:t>
+            </a:r>
+            <a:r>
+              <a:rPr dirty="0"/>
+              <a:t> → User</a:t>
             </a:r>
           </a:p>
         </p:txBody>
@@ -5296,7 +4223,9 @@
         </p:nvSpPr>
         <p:spPr/>
         <p:txBody>
-          <a:bodyPr/>
+          <a:bodyPr>
+            <a:normAutofit fontScale="90000"/>
+          </a:bodyPr>
           <a:lstStyle/>
           <a:p>
             <a:pPr>
@@ -5307,68 +4236,30 @@
               </a:defRPr>
             </a:pPr>
             <a:r>
-              <a:t>Python Code Example – Surface Curvatures</a:t>
-            </a:r>
-          </a:p>
-        </p:txBody>
-      </p:sp>
-      <p:sp>
-        <p:nvSpPr>
-          <p:cNvPr id="4" name="TextBox 3"/>
-          <p:cNvSpPr txBox="1"/>
-          <p:nvPr/>
-        </p:nvSpPr>
-        <p:spPr>
-          <a:xfrm>
-            <a:off x="457200" y="1645920"/>
-            <a:ext cx="8229600" cy="4572000"/>
-          </a:xfrm>
-          <a:prstGeom prst="rect">
-            <a:avLst/>
-          </a:prstGeom>
-          <a:noFill/>
-        </p:spPr>
-        <p:txBody>
-          <a:bodyPr wrap="square">
-            <a:spAutoFit/>
-          </a:bodyPr>
-          <a:lstStyle/>
-          <a:p>
-            <a:endParaRPr/>
-          </a:p>
-          <a:p>
-            <a:pPr>
-              <a:defRPr sz="2200">
-                <a:solidFill>
-                  <a:srgbClr val="FFFFFF"/>
-                </a:solidFill>
-              </a:defRPr>
-            </a:pPr>
-            <a:r>
-              <a:t>E = Xu·Xu     F = Xu·Xv     G = Xv·Xv</a:t>
-            </a:r>
-            <a:br/>
-            <a:r>
-              <a:t>L = n·Xuu     M = n·Xuv     N = n·Xvv</a:t>
-            </a:r>
-            <a:br/>
-            <a:br/>
-            <a:r>
-              <a:t>Gaussian Curvature:</a:t>
-            </a:r>
-            <a:br/>
-            <a:r>
-              <a:t>K = (LN - M²) / (EG - F²)</a:t>
-            </a:r>
-            <a:br/>
-            <a:br/>
-            <a:r>
-              <a:t>Mean Curvature:</a:t>
-            </a:r>
-            <a:br/>
-            <a:r>
-              <a:t>H = (EN + GL - 2FM) / (2(EG - F²))</a:t>
-            </a:r>
+              <a:rPr lang="en-CA" dirty="0"/>
+              <a:t>Curve </a:t>
+            </a:r>
+            <a:r>
+              <a:rPr dirty="0"/>
+              <a:t>Example </a:t>
+            </a:r>
+            <a:r>
+              <a:rPr lang="en-CA" dirty="0"/>
+              <a:t>-</a:t>
+            </a:r>
+            <a:r>
+              <a:rPr dirty="0"/>
+              <a:t> </a:t>
+            </a:r>
+            <a:r>
+              <a:rPr lang="en-CA" dirty="0"/>
+              <a:t>Arc Length </a:t>
+            </a:r>
+            <a:r>
+              <a:rPr lang="en-CA" dirty="0" err="1"/>
+              <a:t>Reparametrization</a:t>
+            </a:r>
+            <a:endParaRPr dirty="0"/>
           </a:p>
         </p:txBody>
       </p:sp>
@@ -5417,7 +4308,9 @@
         </p:nvSpPr>
         <p:spPr/>
         <p:txBody>
-          <a:bodyPr/>
+          <a:bodyPr>
+            <a:normAutofit/>
+          </a:bodyPr>
           <a:lstStyle/>
           <a:p>
             <a:pPr>
@@ -5428,35 +4321,13 @@
               </a:defRPr>
             </a:pPr>
             <a:r>
-              <a:t>Circle Example Diagram</a:t>
-            </a:r>
-          </a:p>
-        </p:txBody>
-      </p:sp>
-      <p:pic>
-        <p:nvPicPr>
-          <p:cNvPr id="3" name="Picture 2" descr="circle.png"/>
-          <p:cNvPicPr>
-            <a:picLocks noChangeAspect="1"/>
-          </p:cNvPicPr>
-          <p:nvPr/>
-        </p:nvPicPr>
-        <p:blipFill>
-          <a:blip r:embed="rId2"/>
-          <a:stretch>
-            <a:fillRect/>
-          </a:stretch>
-        </p:blipFill>
-        <p:spPr>
-          <a:xfrm>
-            <a:off x="914400" y="1828800"/>
-            <a:ext cx="6400800" cy="3840480"/>
-          </a:xfrm>
-          <a:prstGeom prst="rect">
-            <a:avLst/>
-          </a:prstGeom>
-        </p:spPr>
-      </p:pic>
+              <a:rPr lang="en-CA" dirty="0"/>
+              <a:t>Surface Example – Gauss Equations</a:t>
+            </a:r>
+            <a:endParaRPr dirty="0"/>
+          </a:p>
+        </p:txBody>
+      </p:sp>
     </p:spTree>
   </p:cSld>
   <p:clrMapOvr>
@@ -5506,184 +4377,14 @@
           <a:lstStyle/>
           <a:p>
             <a:pPr>
-              <a:defRPr sz="4400">
+              <a:defRPr sz="4000">
                 <a:solidFill>
                   <a:srgbClr val="FFFFFF"/>
                 </a:solidFill>
               </a:defRPr>
             </a:pPr>
             <a:r>
-              <a:t>Helix Example Diagram</a:t>
-            </a:r>
-          </a:p>
-        </p:txBody>
-      </p:sp>
-      <p:pic>
-        <p:nvPicPr>
-          <p:cNvPr id="3" name="Picture 2" descr="helix.png"/>
-          <p:cNvPicPr>
-            <a:picLocks noChangeAspect="1"/>
-          </p:cNvPicPr>
-          <p:nvPr/>
-        </p:nvPicPr>
-        <p:blipFill>
-          <a:blip r:embed="rId2"/>
-          <a:stretch>
-            <a:fillRect/>
-          </a:stretch>
-        </p:blipFill>
-        <p:spPr>
-          <a:xfrm>
-            <a:off x="914400" y="1828800"/>
-            <a:ext cx="6400800" cy="3840480"/>
-          </a:xfrm>
-          <a:prstGeom prst="rect">
-            <a:avLst/>
-          </a:prstGeom>
-        </p:spPr>
-      </p:pic>
-    </p:spTree>
-  </p:cSld>
-  <p:clrMapOvr>
-    <a:masterClrMapping/>
-  </p:clrMapOvr>
-</p:sld>
-</file>
-
-<file path=ppt/slides/slide8.xml><?xml version="1.0" encoding="utf-8"?>
-<p:sld xmlns:a="http://schemas.openxmlformats.org/drawingml/2006/main" xmlns:r="http://schemas.openxmlformats.org/officeDocument/2006/relationships" xmlns:p="http://schemas.openxmlformats.org/presentationml/2006/main">
-  <p:cSld>
-    <p:bg>
-      <p:bgPr>
-        <a:solidFill>
-          <a:srgbClr val="1E1E2D"/>
-        </a:solidFill>
-        <a:effectLst/>
-      </p:bgPr>
-    </p:bg>
-    <p:spTree>
-      <p:nvGrpSpPr>
-        <p:cNvPr id="1" name=""/>
-        <p:cNvGrpSpPr/>
-        <p:nvPr/>
-      </p:nvGrpSpPr>
-      <p:grpSpPr>
-        <a:xfrm>
-          <a:off x="0" y="0"/>
-          <a:ext cx="0" cy="0"/>
-          <a:chOff x="0" y="0"/>
-          <a:chExt cx="0" cy="0"/>
-        </a:xfrm>
-      </p:grpSpPr>
-      <p:sp>
-        <p:nvSpPr>
-          <p:cNvPr id="2" name="Title 1"/>
-          <p:cNvSpPr>
-            <a:spLocks noGrp="1"/>
-          </p:cNvSpPr>
-          <p:nvPr>
-            <p:ph type="title"/>
-          </p:nvPr>
-        </p:nvSpPr>
-        <p:spPr/>
-        <p:txBody>
-          <a:bodyPr/>
-          <a:lstStyle/>
-          <a:p>
-            <a:pPr>
-              <a:defRPr sz="4400">
-                <a:solidFill>
-                  <a:srgbClr val="FFFFFF"/>
-                </a:solidFill>
-              </a:defRPr>
-            </a:pPr>
-            <a:r>
-              <a:t>Paraboloid Example Diagram</a:t>
-            </a:r>
-          </a:p>
-        </p:txBody>
-      </p:sp>
-      <p:pic>
-        <p:nvPicPr>
-          <p:cNvPr id="3" name="Picture 2" descr="paraboloid.png"/>
-          <p:cNvPicPr>
-            <a:picLocks noChangeAspect="1"/>
-          </p:cNvPicPr>
-          <p:nvPr/>
-        </p:nvPicPr>
-        <p:blipFill>
-          <a:blip r:embed="rId2"/>
-          <a:stretch>
-            <a:fillRect/>
-          </a:stretch>
-        </p:blipFill>
-        <p:spPr>
-          <a:xfrm>
-            <a:off x="914400" y="1828800"/>
-            <a:ext cx="6400800" cy="3840480"/>
-          </a:xfrm>
-          <a:prstGeom prst="rect">
-            <a:avLst/>
-          </a:prstGeom>
-        </p:spPr>
-      </p:pic>
-    </p:spTree>
-  </p:cSld>
-  <p:clrMapOvr>
-    <a:masterClrMapping/>
-  </p:clrMapOvr>
-</p:sld>
-</file>
-
-<file path=ppt/slides/slide9.xml><?xml version="1.0" encoding="utf-8"?>
-<p:sld xmlns:a="http://schemas.openxmlformats.org/drawingml/2006/main" xmlns:r="http://schemas.openxmlformats.org/officeDocument/2006/relationships" xmlns:p="http://schemas.openxmlformats.org/presentationml/2006/main">
-  <p:cSld>
-    <p:bg>
-      <p:bgPr>
-        <a:solidFill>
-          <a:srgbClr val="1E1E2D"/>
-        </a:solidFill>
-        <a:effectLst/>
-      </p:bgPr>
-    </p:bg>
-    <p:spTree>
-      <p:nvGrpSpPr>
-        <p:cNvPr id="1" name=""/>
-        <p:cNvGrpSpPr/>
-        <p:nvPr/>
-      </p:nvGrpSpPr>
-      <p:grpSpPr>
-        <a:xfrm>
-          <a:off x="0" y="0"/>
-          <a:ext cx="0" cy="0"/>
-          <a:chOff x="0" y="0"/>
-          <a:chExt cx="0" cy="0"/>
-        </a:xfrm>
-      </p:grpSpPr>
-      <p:sp>
-        <p:nvSpPr>
-          <p:cNvPr id="2" name="Title 1"/>
-          <p:cNvSpPr>
-            <a:spLocks noGrp="1"/>
-          </p:cNvSpPr>
-          <p:nvPr>
-            <p:ph type="title"/>
-          </p:nvPr>
-        </p:nvSpPr>
-        <p:spPr/>
-        <p:txBody>
-          <a:bodyPr/>
-          <a:lstStyle/>
-          <a:p>
-            <a:pPr>
-              <a:defRPr sz="4400">
-                <a:solidFill>
-                  <a:srgbClr val="FFFFFF"/>
-                </a:solidFill>
-              </a:defRPr>
-            </a:pPr>
-            <a:r>
-              <a:t>Formula Animation (Step-by-Step Reveal)</a:t>
+              <a:t>Future Work &amp; Improvements</a:t>
             </a:r>
           </a:p>
         </p:txBody>
@@ -5696,8 +4397,8 @@
         </p:nvSpPr>
         <p:spPr>
           <a:xfrm>
-            <a:off x="914400" y="1828800"/>
-            <a:ext cx="7315200" cy="3657600"/>
+            <a:off x="640080" y="1417638"/>
+            <a:ext cx="7315200" cy="3323987"/>
           </a:xfrm>
           <a:prstGeom prst="rect">
             <a:avLst/>
@@ -5710,7 +4411,7 @@
           </a:bodyPr>
           <a:lstStyle/>
           <a:p>
-            <a:endParaRPr/>
+            <a:endParaRPr dirty="0"/>
           </a:p>
           <a:p>
             <a:pPr>
@@ -5721,27 +4422,52 @@
               </a:defRPr>
             </a:pPr>
             <a:r>
-              <a:t>Step 1: Compute Xu, Xv</a:t>
-            </a:r>
-            <a:br/>
-            <a:r>
-              <a:t>Step 2: Compute E = Xu·Xu, F = Xu·Xv, G = Xv·Xv</a:t>
-            </a:r>
-            <a:br/>
-            <a:r>
-              <a:t>Step 3: Compute Xuu, Xuv, Xvv</a:t>
-            </a:r>
-            <a:br/>
-            <a:r>
-              <a:t>Step 4: Compute L, M, N via n·second derivatives</a:t>
-            </a:r>
-            <a:br/>
-            <a:r>
-              <a:t>Step 5: Compute K = (LN – M²) / (EG – F²)</a:t>
-            </a:r>
-            <a:br/>
-            <a:r>
-              <a:t>Step 6: Compute H = (EN + GL – 2FM) / (2(EG – F²))</a:t>
+              <a:rPr dirty="0"/>
+              <a:t>- Add </a:t>
+            </a:r>
+            <a:r>
+              <a:rPr lang="en-CA" dirty="0"/>
+              <a:t>remaining computations from Shifrin textbook (geodesics, differential forms</a:t>
+            </a:r>
+            <a:r>
+              <a:rPr lang="en-CA"/>
+              <a:t>, etc.)</a:t>
+            </a:r>
+            <a:br>
+              <a:rPr dirty="0"/>
+            </a:br>
+            <a:r>
+              <a:rPr dirty="0"/>
+              <a:t>- Add export options (PDF, PNG, CSV, symbolic)</a:t>
+            </a:r>
+            <a:br>
+              <a:rPr dirty="0"/>
+            </a:br>
+            <a:r>
+              <a:rPr dirty="0"/>
+              <a:t>- </a:t>
+            </a:r>
+            <a:r>
+              <a:rPr lang="en-CA" dirty="0"/>
+              <a:t>Integrate Wolfram Cloud for complete parity with Mathematica’s visual library</a:t>
+            </a:r>
+            <a:br>
+              <a:rPr dirty="0"/>
+            </a:br>
+            <a:r>
+              <a:rPr dirty="0"/>
+              <a:t>- </a:t>
+            </a:r>
+            <a:r>
+              <a:rPr lang="en-CA" dirty="0"/>
+              <a:t>More predictable and user-friendly UI with better error handling</a:t>
+            </a:r>
+            <a:br>
+              <a:rPr dirty="0"/>
+            </a:br>
+            <a:r>
+              <a:rPr dirty="0"/>
+              <a:t>- Add mobile-friendly responsive UI</a:t>
             </a:r>
           </a:p>
         </p:txBody>

</xml_diff>